<commit_message>
model saving + other improvements
</commit_message>
<xml_diff>
--- a/Houdin_Emmanuel_1_présentation_072026.pptx
+++ b/Houdin_Emmanuel_1_présentation_072026.pptx
@@ -5,7 +5,7 @@
     <p:sldMasterId id="2147483888" r:id="rId1"/>
   </p:sldMasterIdLst>
   <p:notesMasterIdLst>
-    <p:notesMasterId r:id="rId15"/>
+    <p:notesMasterId r:id="rId16"/>
   </p:notesMasterIdLst>
   <p:sldIdLst>
     <p:sldId id="256" r:id="rId2"/>
@@ -18,9 +18,10 @@
     <p:sldId id="280" r:id="rId9"/>
     <p:sldId id="281" r:id="rId10"/>
     <p:sldId id="284" r:id="rId11"/>
-    <p:sldId id="264" r:id="rId12"/>
-    <p:sldId id="282" r:id="rId13"/>
-    <p:sldId id="283" r:id="rId14"/>
+    <p:sldId id="285" r:id="rId12"/>
+    <p:sldId id="264" r:id="rId13"/>
+    <p:sldId id="282" r:id="rId14"/>
+    <p:sldId id="283" r:id="rId15"/>
   </p:sldIdLst>
   <p:sldSz cx="12192000" cy="6858000"/>
   <p:notesSz cx="6858000" cy="9144000"/>
@@ -209,7 +210,7 @@
           <a:p>
             <a:fld id="{FCF4711E-C3FA-441C-9148-35EEAD8BD447}" type="datetimeFigureOut">
               <a:rPr lang="fr-FR" smtClean="0"/>
-              <a:t>03/07/2026</a:t>
+              <a:t>23/07/2026</a:t>
             </a:fld>
             <a:endParaRPr lang="fr-FR"/>
           </a:p>
@@ -1062,7 +1063,7 @@
             <a:fld id="{5586B75A-687E-405C-8A0B-8D00578BA2C3}" type="datetimeFigureOut">
               <a:rPr lang="en-US" smtClean="0"/>
               <a:pPr/>
-              <a:t>7/3/2026</a:t>
+              <a:t>7/23/2026</a:t>
             </a:fld>
             <a:endParaRPr lang="en-US" dirty="0"/>
           </a:p>
@@ -1243,7 +1244,7 @@
             <a:fld id="{5586B75A-687E-405C-8A0B-8D00578BA2C3}" type="datetimeFigureOut">
               <a:rPr lang="en-US" smtClean="0"/>
               <a:pPr/>
-              <a:t>7/3/2026</a:t>
+              <a:t>7/23/2026</a:t>
             </a:fld>
             <a:endParaRPr lang="en-US" dirty="0"/>
           </a:p>
@@ -1425,7 +1426,7 @@
             <a:fld id="{5586B75A-687E-405C-8A0B-8D00578BA2C3}" type="datetimeFigureOut">
               <a:rPr lang="en-US" smtClean="0"/>
               <a:pPr/>
-              <a:t>7/3/2026</a:t>
+              <a:t>7/23/2026</a:t>
             </a:fld>
             <a:endParaRPr lang="en-US" dirty="0"/>
           </a:p>
@@ -1597,7 +1598,7 @@
             <a:fld id="{5586B75A-687E-405C-8A0B-8D00578BA2C3}" type="datetimeFigureOut">
               <a:rPr lang="en-US" smtClean="0"/>
               <a:pPr/>
-              <a:t>7/3/2026</a:t>
+              <a:t>7/23/2026</a:t>
             </a:fld>
             <a:endParaRPr lang="en-US" dirty="0"/>
           </a:p>
@@ -1920,7 +1921,7 @@
             <a:fld id="{5586B75A-687E-405C-8A0B-8D00578BA2C3}" type="datetimeFigureOut">
               <a:rPr lang="en-US" smtClean="0"/>
               <a:pPr/>
-              <a:t>7/3/2026</a:t>
+              <a:t>7/23/2026</a:t>
             </a:fld>
             <a:endParaRPr lang="en-US" dirty="0"/>
           </a:p>
@@ -2382,7 +2383,7 @@
             <a:fld id="{5586B75A-687E-405C-8A0B-8D00578BA2C3}" type="datetimeFigureOut">
               <a:rPr lang="en-US" smtClean="0"/>
               <a:pPr/>
-              <a:t>7/3/2026</a:t>
+              <a:t>7/23/2026</a:t>
             </a:fld>
             <a:endParaRPr lang="en-US" dirty="0"/>
           </a:p>
@@ -2795,7 +2796,7 @@
             <a:fld id="{5586B75A-687E-405C-8A0B-8D00578BA2C3}" type="datetimeFigureOut">
               <a:rPr lang="en-US" smtClean="0"/>
               <a:pPr/>
-              <a:t>7/3/2026</a:t>
+              <a:t>7/23/2026</a:t>
             </a:fld>
             <a:endParaRPr lang="en-US" dirty="0"/>
           </a:p>
@@ -2915,7 +2916,7 @@
             <a:fld id="{5586B75A-687E-405C-8A0B-8D00578BA2C3}" type="datetimeFigureOut">
               <a:rPr lang="en-US" smtClean="0"/>
               <a:pPr/>
-              <a:t>7/3/2026</a:t>
+              <a:t>7/23/2026</a:t>
             </a:fld>
             <a:endParaRPr lang="en-US" dirty="0"/>
           </a:p>
@@ -3035,7 +3036,7 @@
             <a:fld id="{5586B75A-687E-405C-8A0B-8D00578BA2C3}" type="datetimeFigureOut">
               <a:rPr lang="en-US" smtClean="0"/>
               <a:pPr/>
-              <a:t>7/3/2026</a:t>
+              <a:t>7/23/2026</a:t>
             </a:fld>
             <a:endParaRPr lang="en-US" dirty="0"/>
           </a:p>
@@ -3395,7 +3396,7 @@
             <a:fld id="{5586B75A-687E-405C-8A0B-8D00578BA2C3}" type="datetimeFigureOut">
               <a:rPr lang="en-US" smtClean="0"/>
               <a:pPr/>
-              <a:t>7/3/2026</a:t>
+              <a:t>7/23/2026</a:t>
             </a:fld>
             <a:endParaRPr lang="en-US" dirty="0"/>
           </a:p>
@@ -3904,7 +3905,7 @@
             <a:fld id="{5586B75A-687E-405C-8A0B-8D00578BA2C3}" type="datetimeFigureOut">
               <a:rPr lang="en-US" smtClean="0"/>
               <a:pPr/>
-              <a:t>7/3/2026</a:t>
+              <a:t>7/23/2026</a:t>
             </a:fld>
             <a:endParaRPr lang="en-US" dirty="0"/>
           </a:p>
@@ -4261,7 +4262,7 @@
             <a:fld id="{5586B75A-687E-405C-8A0B-8D00578BA2C3}" type="datetimeFigureOut">
               <a:rPr lang="en-US" smtClean="0"/>
               <a:pPr/>
-              <a:t>7/3/2026</a:t>
+              <a:t>7/23/2026</a:t>
             </a:fld>
             <a:endParaRPr lang="en-US" dirty="0"/>
           </a:p>
@@ -5037,7 +5038,7 @@
           <a:p>
             <a:r>
               <a:rPr lang="fr-FR" dirty="0"/>
-              <a:t>Training des labels faibles</a:t>
+              <a:t>Training des labels faibles et fine-tuning</a:t>
             </a:r>
           </a:p>
         </p:txBody>
@@ -5070,6 +5071,12 @@
           <a:p>
             <a:r>
               <a:rPr lang="fr-FR" dirty="0"/>
+              <a:t>Recentrage des données utilisées pour la modélisation à 80% de la distance au centroïdes</a:t>
+            </a:r>
+          </a:p>
+          <a:p>
+            <a:r>
+              <a:rPr lang="fr-FR" dirty="0"/>
               <a:t>split du jeu labellisé (80-20 soit 56 images train et 14 test, 5 </a:t>
             </a:r>
             <a:r>
@@ -5098,7 +5105,7 @@
           <a:p>
             <a:r>
               <a:rPr lang="fr-FR" dirty="0"/>
-              <a:t>fine tuning sur labels forts</a:t>
+              <a:t>Fine-tuning sur labels forts</a:t>
             </a:r>
           </a:p>
           <a:p>
@@ -5124,13 +5131,13 @@
           <p:nvPr>
             <p:extLst>
               <p:ext uri="{D42A27DB-BD31-4B8C-83A1-F6EECF244321}">
-                <p14:modId xmlns:p14="http://schemas.microsoft.com/office/powerpoint/2010/main" val="3391085003"/>
+                <p14:modId xmlns:p14="http://schemas.microsoft.com/office/powerpoint/2010/main" val="2899477972"/>
               </p:ext>
             </p:extLst>
           </p:nvPr>
         </p:nvGraphicFramePr>
         <p:xfrm>
-          <a:off x="684091" y="4245023"/>
+          <a:off x="6031222" y="3790120"/>
           <a:ext cx="5268300" cy="1997513"/>
         </p:xfrm>
         <a:graphic>
@@ -5370,7 +5377,7 @@
                         <a:buNone/>
                       </a:pPr>
                       <a:r>
-                        <a:rPr lang="fr-FR" sz="1100" b="0" i="0" u="none" strike="noStrike">
+                        <a:rPr lang="fr-FR" sz="1100" b="0" i="0" u="none" strike="noStrike" dirty="0">
                           <a:solidFill>
                             <a:srgbClr val="000000"/>
                           </a:solidFill>
@@ -7665,6 +7672,346 @@
           <p:cNvPr id="2" name="Titre 1">
             <a:extLst>
               <a:ext uri="{FF2B5EF4-FFF2-40B4-BE49-F238E27FC236}">
+                <a16:creationId xmlns:a16="http://schemas.microsoft.com/office/drawing/2014/main" id="{65412D80-A213-4ADC-8A0A-A93BE40C9435}"/>
+              </a:ext>
+            </a:extLst>
+          </p:cNvPr>
+          <p:cNvSpPr>
+            <a:spLocks noGrp="1"/>
+          </p:cNvSpPr>
+          <p:nvPr>
+            <p:ph type="title"/>
+          </p:nvPr>
+        </p:nvSpPr>
+        <p:spPr/>
+        <p:txBody>
+          <a:bodyPr>
+            <a:normAutofit/>
+          </a:bodyPr>
+          <a:lstStyle/>
+          <a:p>
+            <a:r>
+              <a:rPr lang="fr-FR" sz="4800" dirty="0"/>
+              <a:t>Comparaison des modèles et des </a:t>
+            </a:r>
+            <a:r>
+              <a:rPr lang="fr-FR" sz="4800" dirty="0" err="1"/>
+              <a:t>devices</a:t>
+            </a:r>
+            <a:endParaRPr lang="fr-FR" sz="4800" dirty="0"/>
+          </a:p>
+        </p:txBody>
+      </p:sp>
+      <p:sp>
+        <p:nvSpPr>
+          <p:cNvPr id="3" name="Espace réservé du contenu 2">
+            <a:extLst>
+              <a:ext uri="{FF2B5EF4-FFF2-40B4-BE49-F238E27FC236}">
+                <a16:creationId xmlns:a16="http://schemas.microsoft.com/office/drawing/2014/main" id="{80CA2212-25B9-87BC-6F28-704B2EA4A150}"/>
+              </a:ext>
+            </a:extLst>
+          </p:cNvPr>
+          <p:cNvSpPr>
+            <a:spLocks noGrp="1"/>
+          </p:cNvSpPr>
+          <p:nvPr>
+            <p:ph idx="1"/>
+          </p:nvPr>
+        </p:nvSpPr>
+        <p:spPr>
+          <a:xfrm>
+            <a:off x="7315200" y="2121408"/>
+            <a:ext cx="3813048" cy="4050792"/>
+          </a:xfrm>
+        </p:spPr>
+        <p:txBody>
+          <a:bodyPr/>
+          <a:lstStyle/>
+          <a:p>
+            <a:r>
+              <a:rPr lang="fr-FR" dirty="0"/>
+              <a:t>Utilisation de Google </a:t>
+            </a:r>
+            <a:r>
+              <a:rPr lang="fr-FR" dirty="0" err="1"/>
+              <a:t>Colab</a:t>
+            </a:r>
+            <a:r>
+              <a:rPr lang="fr-FR" dirty="0"/>
+              <a:t>:</a:t>
+            </a:r>
+          </a:p>
+          <a:p>
+            <a:pPr lvl="1"/>
+            <a:r>
+              <a:rPr lang="fr-FR" dirty="0"/>
+              <a:t>Exécution du même modèle ResNet50 10 </a:t>
+            </a:r>
+            <a:r>
+              <a:rPr lang="fr-FR" dirty="0" err="1"/>
+              <a:t>iter</a:t>
+            </a:r>
+            <a:r>
+              <a:rPr lang="fr-FR" dirty="0"/>
+              <a:t> sur un GPU T4 : F1 score 0,889</a:t>
+            </a:r>
+          </a:p>
+          <a:p>
+            <a:pPr marL="0" indent="0">
+              <a:buNone/>
+            </a:pPr>
+            <a:r>
+              <a:rPr lang="fr-FR" dirty="0"/>
+              <a:t>	=&gt; 30’ / 2’30</a:t>
+            </a:r>
+          </a:p>
+          <a:p>
+            <a:pPr lvl="1"/>
+            <a:r>
+              <a:rPr lang="fr-FR" dirty="0"/>
+              <a:t>Exécution de 80 </a:t>
+            </a:r>
+            <a:r>
+              <a:rPr lang="fr-FR" dirty="0" err="1"/>
+              <a:t>iter</a:t>
+            </a:r>
+            <a:r>
+              <a:rPr lang="fr-FR" dirty="0"/>
+              <a:t> avec </a:t>
+            </a:r>
+            <a:r>
+              <a:rPr lang="fr-FR" dirty="0" err="1"/>
+              <a:t>early</a:t>
+            </a:r>
+            <a:r>
+              <a:rPr lang="fr-FR" dirty="0"/>
+              <a:t> </a:t>
+            </a:r>
+            <a:r>
+              <a:rPr lang="fr-FR" dirty="0" err="1"/>
+              <a:t>stopping</a:t>
+            </a:r>
+            <a:r>
+              <a:rPr lang="fr-FR" dirty="0"/>
+              <a:t> à 6 : </a:t>
+            </a:r>
+          </a:p>
+          <a:p>
+            <a:pPr lvl="1"/>
+            <a:r>
+              <a:rPr lang="fr-FR" dirty="0"/>
+              <a:t>F1 score 0,889</a:t>
+            </a:r>
+          </a:p>
+          <a:p>
+            <a:pPr lvl="1"/>
+            <a:endParaRPr lang="fr-FR" dirty="0"/>
+          </a:p>
+          <a:p>
+            <a:pPr lvl="1"/>
+            <a:endParaRPr lang="fr-FR" dirty="0"/>
+          </a:p>
+          <a:p>
+            <a:pPr lvl="1"/>
+            <a:r>
+              <a:rPr lang="fr-FR" dirty="0"/>
+              <a:t>Exécution avec le modèle DenseNet201 sur 80 </a:t>
+            </a:r>
+            <a:r>
+              <a:rPr lang="fr-FR" dirty="0" err="1"/>
+              <a:t>iter</a:t>
+            </a:r>
+            <a:r>
+              <a:rPr lang="fr-FR" dirty="0"/>
+              <a:t> : </a:t>
+            </a:r>
+          </a:p>
+          <a:p>
+            <a:pPr lvl="1"/>
+            <a:r>
+              <a:rPr lang="fr-FR" dirty="0"/>
+              <a:t>F1 score 0,75</a:t>
+            </a:r>
+          </a:p>
+          <a:p>
+            <a:pPr marL="0" indent="0">
+              <a:buNone/>
+            </a:pPr>
+            <a:endParaRPr lang="fr-FR" dirty="0"/>
+          </a:p>
+          <a:p>
+            <a:pPr marL="0" indent="0">
+              <a:buNone/>
+            </a:pPr>
+            <a:endParaRPr lang="fr-FR" dirty="0"/>
+          </a:p>
+        </p:txBody>
+      </p:sp>
+      <p:pic>
+        <p:nvPicPr>
+          <p:cNvPr id="5" name="Image 4">
+            <a:extLst>
+              <a:ext uri="{FF2B5EF4-FFF2-40B4-BE49-F238E27FC236}">
+                <a16:creationId xmlns:a16="http://schemas.microsoft.com/office/drawing/2014/main" id="{9306B6F4-CC91-F7F3-2B4E-5F273A1D2D85}"/>
+              </a:ext>
+            </a:extLst>
+          </p:cNvPr>
+          <p:cNvPicPr>
+            <a:picLocks noChangeAspect="1"/>
+          </p:cNvPicPr>
+          <p:nvPr/>
+        </p:nvPicPr>
+        <p:blipFill>
+          <a:blip r:embed="rId2"/>
+          <a:stretch>
+            <a:fillRect/>
+          </a:stretch>
+        </p:blipFill>
+        <p:spPr>
+          <a:xfrm>
+            <a:off x="940777" y="2451705"/>
+            <a:ext cx="6186762" cy="1972651"/>
+          </a:xfrm>
+          <a:prstGeom prst="rect">
+            <a:avLst/>
+          </a:prstGeom>
+        </p:spPr>
+      </p:pic>
+      <p:sp>
+        <p:nvSpPr>
+          <p:cNvPr id="6" name="ZoneTexte 5">
+            <a:extLst>
+              <a:ext uri="{FF2B5EF4-FFF2-40B4-BE49-F238E27FC236}">
+                <a16:creationId xmlns:a16="http://schemas.microsoft.com/office/drawing/2014/main" id="{A3023E07-B7A0-E298-95BD-8980C743C65A}"/>
+              </a:ext>
+            </a:extLst>
+          </p:cNvPr>
+          <p:cNvSpPr txBox="1"/>
+          <p:nvPr/>
+        </p:nvSpPr>
+        <p:spPr>
+          <a:xfrm>
+            <a:off x="2708031" y="1969480"/>
+            <a:ext cx="2783070" cy="369332"/>
+          </a:xfrm>
+          <a:prstGeom prst="rect">
+            <a:avLst/>
+          </a:prstGeom>
+          <a:noFill/>
+        </p:spPr>
+        <p:txBody>
+          <a:bodyPr wrap="none" rtlCol="0">
+            <a:spAutoFit/>
+          </a:bodyPr>
+          <a:lstStyle/>
+          <a:p>
+            <a:r>
+              <a:rPr lang="fr-FR" dirty="0"/>
+              <a:t>Apprentissage ResNet50</a:t>
+            </a:r>
+          </a:p>
+        </p:txBody>
+      </p:sp>
+      <p:pic>
+        <p:nvPicPr>
+          <p:cNvPr id="8" name="Image 7">
+            <a:extLst>
+              <a:ext uri="{FF2B5EF4-FFF2-40B4-BE49-F238E27FC236}">
+                <a16:creationId xmlns:a16="http://schemas.microsoft.com/office/drawing/2014/main" id="{92E1F56E-3506-47F4-AA01-DE983216C852}"/>
+              </a:ext>
+            </a:extLst>
+          </p:cNvPr>
+          <p:cNvPicPr>
+            <a:picLocks noChangeAspect="1"/>
+          </p:cNvPicPr>
+          <p:nvPr/>
+        </p:nvPicPr>
+        <p:blipFill>
+          <a:blip r:embed="rId3"/>
+          <a:stretch>
+            <a:fillRect/>
+          </a:stretch>
+        </p:blipFill>
+        <p:spPr>
+          <a:xfrm>
+            <a:off x="1054961" y="4788676"/>
+            <a:ext cx="5996470" cy="1983887"/>
+          </a:xfrm>
+          <a:prstGeom prst="rect">
+            <a:avLst/>
+          </a:prstGeom>
+        </p:spPr>
+      </p:pic>
+      <p:sp>
+        <p:nvSpPr>
+          <p:cNvPr id="10" name="ZoneTexte 9">
+            <a:extLst>
+              <a:ext uri="{FF2B5EF4-FFF2-40B4-BE49-F238E27FC236}">
+                <a16:creationId xmlns:a16="http://schemas.microsoft.com/office/drawing/2014/main" id="{FA522BEE-B895-B611-49D5-C555D9623FA3}"/>
+              </a:ext>
+            </a:extLst>
+          </p:cNvPr>
+          <p:cNvSpPr txBox="1"/>
+          <p:nvPr/>
+        </p:nvSpPr>
+        <p:spPr>
+          <a:xfrm>
+            <a:off x="2517531" y="4480921"/>
+            <a:ext cx="3203056" cy="369332"/>
+          </a:xfrm>
+          <a:prstGeom prst="rect">
+            <a:avLst/>
+          </a:prstGeom>
+          <a:noFill/>
+        </p:spPr>
+        <p:txBody>
+          <a:bodyPr wrap="none" rtlCol="0">
+            <a:spAutoFit/>
+          </a:bodyPr>
+          <a:lstStyle/>
+          <a:p>
+            <a:r>
+              <a:rPr lang="fr-FR" dirty="0"/>
+              <a:t>Apprentissage DenseNet201</a:t>
+            </a:r>
+          </a:p>
+        </p:txBody>
+      </p:sp>
+    </p:spTree>
+    <p:extLst>
+      <p:ext uri="{BB962C8B-B14F-4D97-AF65-F5344CB8AC3E}">
+        <p14:creationId xmlns:p14="http://schemas.microsoft.com/office/powerpoint/2010/main" val="1693839545"/>
+      </p:ext>
+    </p:extLst>
+  </p:cSld>
+  <p:clrMapOvr>
+    <a:masterClrMapping/>
+  </p:clrMapOvr>
+</p:sld>
+</file>
+
+<file path=ppt/slides/slide12.xml><?xml version="1.0" encoding="utf-8"?>
+<p:sld xmlns:a="http://schemas.openxmlformats.org/drawingml/2006/main" xmlns:r="http://schemas.openxmlformats.org/officeDocument/2006/relationships" xmlns:p="http://schemas.openxmlformats.org/presentationml/2006/main">
+  <p:cSld>
+    <p:spTree>
+      <p:nvGrpSpPr>
+        <p:cNvPr id="1" name=""/>
+        <p:cNvGrpSpPr/>
+        <p:nvPr/>
+      </p:nvGrpSpPr>
+      <p:grpSpPr>
+        <a:xfrm>
+          <a:off x="0" y="0"/>
+          <a:ext cx="0" cy="0"/>
+          <a:chOff x="0" y="0"/>
+          <a:chExt cx="0" cy="0"/>
+        </a:xfrm>
+      </p:grpSpPr>
+      <p:sp>
+        <p:nvSpPr>
+          <p:cNvPr id="2" name="Titre 1">
+            <a:extLst>
+              <a:ext uri="{FF2B5EF4-FFF2-40B4-BE49-F238E27FC236}">
                 <a16:creationId xmlns:a16="http://schemas.microsoft.com/office/drawing/2014/main" id="{ABCD686D-1128-94DD-1B3F-E166A506EFCE}"/>
               </a:ext>
             </a:extLst>
@@ -7726,48 +8073,31 @@
           <a:p>
             <a:r>
               <a:rPr lang="fr-FR" dirty="0"/>
-              <a:t>Cette étape n'est pas utilisée directement pour l'évaluation du CNN.</a:t>
+              <a:t>La supervision des images labellisées donne le même score. Donc l'ajout des données faiblement labellisées n'apporte pas d'amélioration mesurable des performances.</a:t>
             </a:r>
           </a:p>
           <a:p>
             <a:r>
               <a:rPr lang="fr-FR" dirty="0"/>
-              <a:t>Le split a été fait uniquement à partir de la semi-supervision et fine tuning sur labels forts.</a:t>
-            </a:r>
+              <a:t>Pour ce cas présent DenseNet201 n’apporte pas d’amélioration</a:t>
+            </a:r>
+          </a:p>
+          <a:p>
+            <a:endParaRPr lang="fr-FR" dirty="0"/>
           </a:p>
           <a:p>
             <a:r>
               <a:rPr lang="fr-FR" dirty="0"/>
-              <a:t>La supervision des images labellisées donne le même score</a:t>
-            </a:r>
-          </a:p>
-          <a:p>
+              <a:t>Il faudrait plus d’images fortement labellisées =&gt; budget pour achat GPU ou PTF type </a:t>
+            </a:r>
+            <a:r>
+              <a:rPr lang="fr-FR" dirty="0" err="1"/>
+              <a:t>Colab</a:t>
+            </a:r>
             <a:r>
               <a:rPr lang="fr-FR" dirty="0"/>
-              <a:t>Donc l'ajout des données faiblement labellisées n'apporte pas d'amélioration mesurable des performances.</a:t>
-            </a:r>
-          </a:p>
-          <a:p>
-            <a:endParaRPr lang="fr-FR" dirty="0"/>
-          </a:p>
-          <a:p>
-            <a:r>
-              <a:rPr lang="fr-FR" dirty="0"/>
-              <a:t>Pour être plus précis il faudrait réaliser les </a:t>
-            </a:r>
-            <a:r>
-              <a:rPr lang="fr-FR" dirty="0" err="1"/>
-              <a:t>folds</a:t>
-            </a:r>
-            <a:r>
-              <a:rPr lang="fr-FR" dirty="0"/>
-              <a:t> avant le </a:t>
-            </a:r>
-            <a:r>
-              <a:rPr lang="fr-FR" dirty="0" err="1"/>
-              <a:t>Kmeans</a:t>
-            </a:r>
-            <a:endParaRPr lang="fr-FR" dirty="0"/>
+              <a:t> Pro (50€/mois)</a:t>
+            </a:r>
           </a:p>
           <a:p>
             <a:r>
@@ -7788,7 +8118,13 @@
             </a:r>
             <a:r>
               <a:rPr lang="fr-FR" dirty="0"/>
-              <a:t>)</a:t>
+              <a:t>). Dans l’idéal, plusieurs vues d’un même patient.</a:t>
+            </a:r>
+          </a:p>
+          <a:p>
+            <a:r>
+              <a:rPr lang="fr-FR" dirty="0"/>
+              <a:t>Construire un pipeline pour analyser de nouvelles IRM.</a:t>
             </a:r>
           </a:p>
         </p:txBody>
@@ -7806,7 +8142,7 @@
 </p:sld>
 </file>
 
-<file path=ppt/slides/slide12.xml><?xml version="1.0" encoding="utf-8"?>
+<file path=ppt/slides/slide13.xml><?xml version="1.0" encoding="utf-8"?>
 <p:sld xmlns:a="http://schemas.openxmlformats.org/drawingml/2006/main" xmlns:r="http://schemas.openxmlformats.org/officeDocument/2006/relationships" xmlns:p="http://schemas.openxmlformats.org/presentationml/2006/main">
   <p:cSld>
     <p:spTree>
@@ -7943,7 +8279,7 @@
 </p:sld>
 </file>
 
-<file path=ppt/slides/slide13.xml><?xml version="1.0" encoding="utf-8"?>
+<file path=ppt/slides/slide14.xml><?xml version="1.0" encoding="utf-8"?>
 <p:sld xmlns:a="http://schemas.openxmlformats.org/drawingml/2006/main" xmlns:r="http://schemas.openxmlformats.org/officeDocument/2006/relationships" xmlns:p="http://schemas.openxmlformats.org/presentationml/2006/main">
   <p:cSld>
     <p:spTree>
@@ -8004,12 +8340,20 @@
             <p:ph idx="1"/>
           </p:nvPr>
         </p:nvSpPr>
-        <p:spPr/>
+        <p:spPr>
+          <a:xfrm>
+            <a:off x="6348046" y="2121408"/>
+            <a:ext cx="4780202" cy="4050792"/>
+          </a:xfrm>
+        </p:spPr>
         <p:txBody>
           <a:bodyPr/>
           <a:lstStyle/>
           <a:p>
-            <a:endParaRPr lang="fr-FR"/>
+            <a:r>
+              <a:rPr lang="fr-FR" dirty="0"/>
+              <a:t>Recentrage des données utilisées pour la modélisation à 80% de la distance au centroïdes</a:t>
+            </a:r>
           </a:p>
         </p:txBody>
       </p:sp>
@@ -8223,7 +8567,7 @@
           <a:p>
             <a:r>
               <a:rPr lang="fr-FR" dirty="0"/>
-              <a:t>1- Explorer les images</a:t>
+              <a:t>Explorer les images</a:t>
             </a:r>
           </a:p>
         </p:txBody>
@@ -8364,7 +8708,7 @@
           <a:p>
             <a:r>
               <a:rPr lang="fr-FR" dirty="0"/>
-              <a:t>1- Extraire des caractéristiques visuelles</a:t>
+              <a:t>Extraire des caractéristiques visuelles</a:t>
             </a:r>
           </a:p>
         </p:txBody>
@@ -8963,7 +9307,7 @@
           <a:p>
             <a:r>
               <a:rPr lang="fr-FR" dirty="0"/>
-              <a:t>2- Extraction des </a:t>
+              <a:t>Extraction des </a:t>
             </a:r>
             <a:r>
               <a:rPr lang="fr-FR" dirty="0" err="1"/>

</xml_diff>

<commit_message>
minor improvements and comments
</commit_message>
<xml_diff>
--- a/Houdin_Emmanuel_1_présentation_072026.pptx
+++ b/Houdin_Emmanuel_1_présentation_072026.pptx
@@ -18,10 +18,10 @@
     <p:sldId id="280" r:id="rId9"/>
     <p:sldId id="281" r:id="rId10"/>
     <p:sldId id="284" r:id="rId11"/>
-    <p:sldId id="285" r:id="rId12"/>
-    <p:sldId id="264" r:id="rId13"/>
-    <p:sldId id="282" r:id="rId14"/>
-    <p:sldId id="283" r:id="rId15"/>
+    <p:sldId id="286" r:id="rId12"/>
+    <p:sldId id="285" r:id="rId13"/>
+    <p:sldId id="264" r:id="rId14"/>
+    <p:sldId id="282" r:id="rId15"/>
   </p:sldIdLst>
   <p:sldSz cx="12192000" cy="6858000"/>
   <p:notesSz cx="6858000" cy="9144000"/>
@@ -210,7 +210,7 @@
           <a:p>
             <a:fld id="{FCF4711E-C3FA-441C-9148-35EEAD8BD447}" type="datetimeFigureOut">
               <a:rPr lang="fr-FR" smtClean="0"/>
-              <a:t>23/07/2026</a:t>
+              <a:t>27/07/2026</a:t>
             </a:fld>
             <a:endParaRPr lang="fr-FR"/>
           </a:p>
@@ -1063,7 +1063,7 @@
             <a:fld id="{5586B75A-687E-405C-8A0B-8D00578BA2C3}" type="datetimeFigureOut">
               <a:rPr lang="en-US" smtClean="0"/>
               <a:pPr/>
-              <a:t>7/23/2026</a:t>
+              <a:t>7/27/2026</a:t>
             </a:fld>
             <a:endParaRPr lang="en-US" dirty="0"/>
           </a:p>
@@ -1244,7 +1244,7 @@
             <a:fld id="{5586B75A-687E-405C-8A0B-8D00578BA2C3}" type="datetimeFigureOut">
               <a:rPr lang="en-US" smtClean="0"/>
               <a:pPr/>
-              <a:t>7/23/2026</a:t>
+              <a:t>7/27/2026</a:t>
             </a:fld>
             <a:endParaRPr lang="en-US" dirty="0"/>
           </a:p>
@@ -1426,7 +1426,7 @@
             <a:fld id="{5586B75A-687E-405C-8A0B-8D00578BA2C3}" type="datetimeFigureOut">
               <a:rPr lang="en-US" smtClean="0"/>
               <a:pPr/>
-              <a:t>7/23/2026</a:t>
+              <a:t>7/27/2026</a:t>
             </a:fld>
             <a:endParaRPr lang="en-US" dirty="0"/>
           </a:p>
@@ -1598,7 +1598,7 @@
             <a:fld id="{5586B75A-687E-405C-8A0B-8D00578BA2C3}" type="datetimeFigureOut">
               <a:rPr lang="en-US" smtClean="0"/>
               <a:pPr/>
-              <a:t>7/23/2026</a:t>
+              <a:t>7/27/2026</a:t>
             </a:fld>
             <a:endParaRPr lang="en-US" dirty="0"/>
           </a:p>
@@ -1921,7 +1921,7 @@
             <a:fld id="{5586B75A-687E-405C-8A0B-8D00578BA2C3}" type="datetimeFigureOut">
               <a:rPr lang="en-US" smtClean="0"/>
               <a:pPr/>
-              <a:t>7/23/2026</a:t>
+              <a:t>7/27/2026</a:t>
             </a:fld>
             <a:endParaRPr lang="en-US" dirty="0"/>
           </a:p>
@@ -2383,7 +2383,7 @@
             <a:fld id="{5586B75A-687E-405C-8A0B-8D00578BA2C3}" type="datetimeFigureOut">
               <a:rPr lang="en-US" smtClean="0"/>
               <a:pPr/>
-              <a:t>7/23/2026</a:t>
+              <a:t>7/27/2026</a:t>
             </a:fld>
             <a:endParaRPr lang="en-US" dirty="0"/>
           </a:p>
@@ -2796,7 +2796,7 @@
             <a:fld id="{5586B75A-687E-405C-8A0B-8D00578BA2C3}" type="datetimeFigureOut">
               <a:rPr lang="en-US" smtClean="0"/>
               <a:pPr/>
-              <a:t>7/23/2026</a:t>
+              <a:t>7/27/2026</a:t>
             </a:fld>
             <a:endParaRPr lang="en-US" dirty="0"/>
           </a:p>
@@ -2916,7 +2916,7 @@
             <a:fld id="{5586B75A-687E-405C-8A0B-8D00578BA2C3}" type="datetimeFigureOut">
               <a:rPr lang="en-US" smtClean="0"/>
               <a:pPr/>
-              <a:t>7/23/2026</a:t>
+              <a:t>7/27/2026</a:t>
             </a:fld>
             <a:endParaRPr lang="en-US" dirty="0"/>
           </a:p>
@@ -3036,7 +3036,7 @@
             <a:fld id="{5586B75A-687E-405C-8A0B-8D00578BA2C3}" type="datetimeFigureOut">
               <a:rPr lang="en-US" smtClean="0"/>
               <a:pPr/>
-              <a:t>7/23/2026</a:t>
+              <a:t>7/27/2026</a:t>
             </a:fld>
             <a:endParaRPr lang="en-US" dirty="0"/>
           </a:p>
@@ -3396,7 +3396,7 @@
             <a:fld id="{5586B75A-687E-405C-8A0B-8D00578BA2C3}" type="datetimeFigureOut">
               <a:rPr lang="en-US" smtClean="0"/>
               <a:pPr/>
-              <a:t>7/23/2026</a:t>
+              <a:t>7/27/2026</a:t>
             </a:fld>
             <a:endParaRPr lang="en-US" dirty="0"/>
           </a:p>
@@ -3905,7 +3905,7 @@
             <a:fld id="{5586B75A-687E-405C-8A0B-8D00578BA2C3}" type="datetimeFigureOut">
               <a:rPr lang="en-US" smtClean="0"/>
               <a:pPr/>
-              <a:t>7/23/2026</a:t>
+              <a:t>7/27/2026</a:t>
             </a:fld>
             <a:endParaRPr lang="en-US" dirty="0"/>
           </a:p>
@@ -4262,7 +4262,7 @@
             <a:fld id="{5586B75A-687E-405C-8A0B-8D00578BA2C3}" type="datetimeFigureOut">
               <a:rPr lang="en-US" smtClean="0"/>
               <a:pPr/>
-              <a:t>7/23/2026</a:t>
+              <a:t>7/27/2026</a:t>
             </a:fld>
             <a:endParaRPr lang="en-US" dirty="0"/>
           </a:p>
@@ -5038,7 +5038,14 @@
           <a:p>
             <a:r>
               <a:rPr lang="fr-FR" dirty="0"/>
-              <a:t>Training des labels faibles et fine-tuning</a:t>
+              <a:t>Training des labels</a:t>
+            </a:r>
+            <a:br>
+              <a:rPr lang="fr-FR" dirty="0"/>
+            </a:br>
+            <a:r>
+              <a:rPr lang="fr-FR" dirty="0"/>
+              <a:t>fiabilisation des données</a:t>
             </a:r>
           </a:p>
         </p:txBody>
@@ -5061,6 +5068,148 @@
         </p:nvSpPr>
         <p:spPr>
           <a:xfrm>
+            <a:off x="437693" y="3166638"/>
+            <a:ext cx="5832114" cy="2012032"/>
+          </a:xfrm>
+        </p:spPr>
+        <p:txBody>
+          <a:bodyPr/>
+          <a:lstStyle/>
+          <a:p>
+            <a:r>
+              <a:rPr lang="fr-FR" dirty="0"/>
+              <a:t>Optimisation des distances des données utilisées par rapport aux centroïdes</a:t>
+            </a:r>
+          </a:p>
+          <a:p>
+            <a:r>
+              <a:rPr lang="fr-FR" dirty="0"/>
+              <a:t>On teste 80%, 90%, 100%</a:t>
+            </a:r>
+          </a:p>
+          <a:p>
+            <a:r>
+              <a:rPr lang="fr-FR" dirty="0"/>
+              <a:t>=&gt; images mieux triées mais moins d’images</a:t>
+            </a:r>
+          </a:p>
+          <a:p>
+            <a:endParaRPr lang="fr-FR" dirty="0"/>
+          </a:p>
+        </p:txBody>
+      </p:sp>
+      <p:pic>
+        <p:nvPicPr>
+          <p:cNvPr id="6" name="Image 5">
+            <a:extLst>
+              <a:ext uri="{FF2B5EF4-FFF2-40B4-BE49-F238E27FC236}">
+                <a16:creationId xmlns:a16="http://schemas.microsoft.com/office/drawing/2014/main" id="{B432A802-F7EF-E6CB-4D6D-EB1BB633DB79}"/>
+              </a:ext>
+            </a:extLst>
+          </p:cNvPr>
+          <p:cNvPicPr>
+            <a:picLocks noChangeAspect="1"/>
+          </p:cNvPicPr>
+          <p:nvPr/>
+        </p:nvPicPr>
+        <p:blipFill>
+          <a:blip r:embed="rId2"/>
+          <a:stretch>
+            <a:fillRect/>
+          </a:stretch>
+        </p:blipFill>
+        <p:spPr>
+          <a:xfrm>
+            <a:off x="6269807" y="2542384"/>
+            <a:ext cx="4991973" cy="3410009"/>
+          </a:xfrm>
+          <a:prstGeom prst="rect">
+            <a:avLst/>
+          </a:prstGeom>
+        </p:spPr>
+      </p:pic>
+    </p:spTree>
+    <p:extLst>
+      <p:ext uri="{BB962C8B-B14F-4D97-AF65-F5344CB8AC3E}">
+        <p14:creationId xmlns:p14="http://schemas.microsoft.com/office/powerpoint/2010/main" val="3870860903"/>
+      </p:ext>
+    </p:extLst>
+  </p:cSld>
+  <p:clrMapOvr>
+    <a:masterClrMapping/>
+  </p:clrMapOvr>
+</p:sld>
+</file>
+
+<file path=ppt/slides/slide11.xml><?xml version="1.0" encoding="utf-8"?>
+<p:sld xmlns:a="http://schemas.openxmlformats.org/drawingml/2006/main" xmlns:r="http://schemas.openxmlformats.org/officeDocument/2006/relationships" xmlns:p="http://schemas.openxmlformats.org/presentationml/2006/main">
+  <p:cSld>
+    <p:spTree>
+      <p:nvGrpSpPr>
+        <p:cNvPr id="1" name="">
+          <a:extLst>
+            <a:ext uri="{FF2B5EF4-FFF2-40B4-BE49-F238E27FC236}">
+              <a16:creationId xmlns:a16="http://schemas.microsoft.com/office/drawing/2014/main" id="{E09659AF-DE13-0158-5F6D-A37A6118147F}"/>
+            </a:ext>
+          </a:extLst>
+        </p:cNvPr>
+        <p:cNvGrpSpPr/>
+        <p:nvPr/>
+      </p:nvGrpSpPr>
+      <p:grpSpPr>
+        <a:xfrm>
+          <a:off x="0" y="0"/>
+          <a:ext cx="0" cy="0"/>
+          <a:chOff x="0" y="0"/>
+          <a:chExt cx="0" cy="0"/>
+        </a:xfrm>
+      </p:grpSpPr>
+      <p:sp>
+        <p:nvSpPr>
+          <p:cNvPr id="2" name="Titre 1">
+            <a:extLst>
+              <a:ext uri="{FF2B5EF4-FFF2-40B4-BE49-F238E27FC236}">
+                <a16:creationId xmlns:a16="http://schemas.microsoft.com/office/drawing/2014/main" id="{04474D5F-0435-D480-4ACC-AB70CEFE81B9}"/>
+              </a:ext>
+            </a:extLst>
+          </p:cNvPr>
+          <p:cNvSpPr>
+            <a:spLocks noGrp="1"/>
+          </p:cNvSpPr>
+          <p:nvPr>
+            <p:ph type="title"/>
+          </p:nvPr>
+        </p:nvSpPr>
+        <p:spPr/>
+        <p:txBody>
+          <a:bodyPr/>
+          <a:lstStyle/>
+          <a:p>
+            <a:r>
+              <a:rPr lang="fr-FR" dirty="0"/>
+              <a:t>Training des labels faibles et fine-tuning</a:t>
+            </a:r>
+          </a:p>
+        </p:txBody>
+      </p:sp>
+      <p:sp>
+        <p:nvSpPr>
+          <p:cNvPr id="3" name="Espace réservé du contenu 2">
+            <a:extLst>
+              <a:ext uri="{FF2B5EF4-FFF2-40B4-BE49-F238E27FC236}">
+                <a16:creationId xmlns:a16="http://schemas.microsoft.com/office/drawing/2014/main" id="{A2194ABC-ECBC-DC54-2DF9-C67A9BC8E496}"/>
+              </a:ext>
+            </a:extLst>
+          </p:cNvPr>
+          <p:cNvSpPr>
+            <a:spLocks noGrp="1"/>
+          </p:cNvSpPr>
+          <p:nvPr>
+            <p:ph idx="1"/>
+          </p:nvPr>
+        </p:nvSpPr>
+        <p:spPr>
+          <a:xfrm>
             <a:off x="603855" y="2121407"/>
             <a:ext cx="5832114" cy="4534369"/>
           </a:xfrm>
@@ -5071,12 +5220,6 @@
           <a:p>
             <a:r>
               <a:rPr lang="fr-FR" dirty="0"/>
-              <a:t>Recentrage des données utilisées pour la modélisation à 80% de la distance au centroïdes</a:t>
-            </a:r>
-          </a:p>
-          <a:p>
-            <a:r>
-              <a:rPr lang="fr-FR" dirty="0"/>
               <a:t>split du jeu labellisé (80-20 soit 56 images train et 14 test, 5 </a:t>
             </a:r>
             <a:r>
@@ -5121,20 +5264,14 @@
           <p:cNvPr id="7" name="Tableau 6">
             <a:extLst>
               <a:ext uri="{FF2B5EF4-FFF2-40B4-BE49-F238E27FC236}">
-                <a16:creationId xmlns:a16="http://schemas.microsoft.com/office/drawing/2014/main" id="{00EE9864-A87E-023C-2A76-93D952CAC81B}"/>
+                <a16:creationId xmlns:a16="http://schemas.microsoft.com/office/drawing/2014/main" id="{967717FC-338A-117E-0B53-EF1C014E9383}"/>
               </a:ext>
             </a:extLst>
           </p:cNvPr>
           <p:cNvGraphicFramePr>
             <a:graphicFrameLocks noGrp="1"/>
           </p:cNvGraphicFramePr>
-          <p:nvPr>
-            <p:extLst>
-              <p:ext uri="{D42A27DB-BD31-4B8C-83A1-F6EECF244321}">
-                <p14:modId xmlns:p14="http://schemas.microsoft.com/office/powerpoint/2010/main" val="2899477972"/>
-              </p:ext>
-            </p:extLst>
-          </p:nvPr>
+          <p:nvPr/>
         </p:nvGraphicFramePr>
         <p:xfrm>
           <a:off x="6031222" y="3790120"/>
@@ -7359,7 +7496,7 @@
           <p:cNvPr id="4" name="Espace réservé du contenu 2">
             <a:extLst>
               <a:ext uri="{FF2B5EF4-FFF2-40B4-BE49-F238E27FC236}">
-                <a16:creationId xmlns:a16="http://schemas.microsoft.com/office/drawing/2014/main" id="{64B4AD87-0366-4390-5694-CA93C2B51E23}"/>
+                <a16:creationId xmlns:a16="http://schemas.microsoft.com/office/drawing/2014/main" id="{3D987A3B-366F-55F5-C864-25AC02408F72}"/>
               </a:ext>
             </a:extLst>
           </p:cNvPr>
@@ -7640,7 +7777,7 @@
     </p:spTree>
     <p:extLst>
       <p:ext uri="{BB962C8B-B14F-4D97-AF65-F5344CB8AC3E}">
-        <p14:creationId xmlns:p14="http://schemas.microsoft.com/office/powerpoint/2010/main" val="3870860903"/>
+        <p14:creationId xmlns:p14="http://schemas.microsoft.com/office/powerpoint/2010/main" val="2436728102"/>
       </p:ext>
     </p:extLst>
   </p:cSld>
@@ -7650,7 +7787,7 @@
 </p:sld>
 </file>
 
-<file path=ppt/slides/slide11.xml><?xml version="1.0" encoding="utf-8"?>
+<file path=ppt/slides/slide12.xml><?xml version="1.0" encoding="utf-8"?>
 <p:sld xmlns:a="http://schemas.openxmlformats.org/drawingml/2006/main" xmlns:r="http://schemas.openxmlformats.org/officeDocument/2006/relationships" xmlns:p="http://schemas.openxmlformats.org/presentationml/2006/main">
   <p:cSld>
     <p:spTree>
@@ -7990,7 +8127,7 @@
 </p:sld>
 </file>
 
-<file path=ppt/slides/slide12.xml><?xml version="1.0" encoding="utf-8"?>
+<file path=ppt/slides/slide13.xml><?xml version="1.0" encoding="utf-8"?>
 <p:sld xmlns:a="http://schemas.openxmlformats.org/drawingml/2006/main" xmlns:r="http://schemas.openxmlformats.org/officeDocument/2006/relationships" xmlns:p="http://schemas.openxmlformats.org/presentationml/2006/main">
   <p:cSld>
     <p:spTree>
@@ -8142,7 +8279,7 @@
 </p:sld>
 </file>
 
-<file path=ppt/slides/slide13.xml><?xml version="1.0" encoding="utf-8"?>
+<file path=ppt/slides/slide14.xml><?xml version="1.0" encoding="utf-8"?>
 <p:sld xmlns:a="http://schemas.openxmlformats.org/drawingml/2006/main" xmlns:r="http://schemas.openxmlformats.org/officeDocument/2006/relationships" xmlns:p="http://schemas.openxmlformats.org/presentationml/2006/main">
   <p:cSld>
     <p:spTree>
@@ -8270,127 +8407,6 @@
     <p:extLst>
       <p:ext uri="{BB962C8B-B14F-4D97-AF65-F5344CB8AC3E}">
         <p14:creationId xmlns:p14="http://schemas.microsoft.com/office/powerpoint/2010/main" val="1635644137"/>
-      </p:ext>
-    </p:extLst>
-  </p:cSld>
-  <p:clrMapOvr>
-    <a:masterClrMapping/>
-  </p:clrMapOvr>
-</p:sld>
-</file>
-
-<file path=ppt/slides/slide14.xml><?xml version="1.0" encoding="utf-8"?>
-<p:sld xmlns:a="http://schemas.openxmlformats.org/drawingml/2006/main" xmlns:r="http://schemas.openxmlformats.org/officeDocument/2006/relationships" xmlns:p="http://schemas.openxmlformats.org/presentationml/2006/main">
-  <p:cSld>
-    <p:spTree>
-      <p:nvGrpSpPr>
-        <p:cNvPr id="1" name=""/>
-        <p:cNvGrpSpPr/>
-        <p:nvPr/>
-      </p:nvGrpSpPr>
-      <p:grpSpPr>
-        <a:xfrm>
-          <a:off x="0" y="0"/>
-          <a:ext cx="0" cy="0"/>
-          <a:chOff x="0" y="0"/>
-          <a:chExt cx="0" cy="0"/>
-        </a:xfrm>
-      </p:grpSpPr>
-      <p:sp>
-        <p:nvSpPr>
-          <p:cNvPr id="2" name="Titre 1">
-            <a:extLst>
-              <a:ext uri="{FF2B5EF4-FFF2-40B4-BE49-F238E27FC236}">
-                <a16:creationId xmlns:a16="http://schemas.microsoft.com/office/drawing/2014/main" id="{0FB68CB0-B853-6E5F-B27E-4F5346A9C538}"/>
-              </a:ext>
-            </a:extLst>
-          </p:cNvPr>
-          <p:cNvSpPr>
-            <a:spLocks noGrp="1"/>
-          </p:cNvSpPr>
-          <p:nvPr>
-            <p:ph type="title"/>
-          </p:nvPr>
-        </p:nvSpPr>
-        <p:spPr/>
-        <p:txBody>
-          <a:bodyPr/>
-          <a:lstStyle/>
-          <a:p>
-            <a:r>
-              <a:rPr lang="fr-FR" dirty="0"/>
-              <a:t>Clustering optimisation</a:t>
-            </a:r>
-          </a:p>
-        </p:txBody>
-      </p:sp>
-      <p:sp>
-        <p:nvSpPr>
-          <p:cNvPr id="3" name="Espace réservé du contenu 2">
-            <a:extLst>
-              <a:ext uri="{FF2B5EF4-FFF2-40B4-BE49-F238E27FC236}">
-                <a16:creationId xmlns:a16="http://schemas.microsoft.com/office/drawing/2014/main" id="{0FFC61DF-EB9A-DD24-C909-C881B13BF33F}"/>
-              </a:ext>
-            </a:extLst>
-          </p:cNvPr>
-          <p:cNvSpPr>
-            <a:spLocks noGrp="1"/>
-          </p:cNvSpPr>
-          <p:nvPr>
-            <p:ph idx="1"/>
-          </p:nvPr>
-        </p:nvSpPr>
-        <p:spPr>
-          <a:xfrm>
-            <a:off x="6348046" y="2121408"/>
-            <a:ext cx="4780202" cy="4050792"/>
-          </a:xfrm>
-        </p:spPr>
-        <p:txBody>
-          <a:bodyPr/>
-          <a:lstStyle/>
-          <a:p>
-            <a:r>
-              <a:rPr lang="fr-FR" dirty="0"/>
-              <a:t>Recentrage des données utilisées pour la modélisation à 80% de la distance au centroïdes</a:t>
-            </a:r>
-          </a:p>
-        </p:txBody>
-      </p:sp>
-      <p:pic>
-        <p:nvPicPr>
-          <p:cNvPr id="5" name="Image 4">
-            <a:extLst>
-              <a:ext uri="{FF2B5EF4-FFF2-40B4-BE49-F238E27FC236}">
-                <a16:creationId xmlns:a16="http://schemas.microsoft.com/office/drawing/2014/main" id="{6F241169-3120-17A8-DFF5-0C529B52A62E}"/>
-              </a:ext>
-            </a:extLst>
-          </p:cNvPr>
-          <p:cNvPicPr>
-            <a:picLocks noChangeAspect="1"/>
-          </p:cNvPicPr>
-          <p:nvPr/>
-        </p:nvPicPr>
-        <p:blipFill>
-          <a:blip r:embed="rId2"/>
-          <a:stretch>
-            <a:fillRect/>
-          </a:stretch>
-        </p:blipFill>
-        <p:spPr>
-          <a:xfrm>
-            <a:off x="563599" y="2762191"/>
-            <a:ext cx="4991973" cy="3410009"/>
-          </a:xfrm>
-          <a:prstGeom prst="rect">
-            <a:avLst/>
-          </a:prstGeom>
-        </p:spPr>
-      </p:pic>
-    </p:spTree>
-    <p:extLst>
-      <p:ext uri="{BB962C8B-B14F-4D97-AF65-F5344CB8AC3E}">
-        <p14:creationId xmlns:p14="http://schemas.microsoft.com/office/powerpoint/2010/main" val="2201070604"/>
       </p:ext>
     </p:extLst>
   </p:cSld>
@@ -10711,7 +10727,7 @@
         </p:spPr>
         <p:txBody>
           <a:bodyPr>
-            <a:normAutofit/>
+            <a:normAutofit fontScale="70000" lnSpcReduction="20000"/>
           </a:bodyPr>
           <a:lstStyle/>
           <a:p>
@@ -10720,7 +10736,7 @@
             </a:pPr>
             <a:r>
               <a:rPr lang="fr-FR" dirty="0"/>
-              <a:t>« Normaux » et « cancer » sont assez bien séparés</a:t>
+              <a:t>Projection UMAP sur les labels forts =&gt; « normaux » et « cancer » sont assez bien séparés</a:t>
             </a:r>
           </a:p>
         </p:txBody>

</xml_diff>